<commit_message>
Set tactic week to Wed 23 - Tue 29 Sep; re-date schedule
Preparation keeps its real dates (23-27 Sep); all v1 outreach and Cape
Coast canvassing on Mon 28 - Tue 29 Sep; v2 and 10 interviews on
Wed 30 Sep - Tue 6 Oct; findings due Wed 7 Oct. The eight-week plan,
deadlines and decision record now run Wednesday to Tuesday.

Co-Authored-By: Claude Opus 5.5 <noreply@anthropic.com>
Claude-Session: https://claude.ai/code/session_014DwxjU8rHfrSVBV6irvX7Y
</commit_message>
<xml_diff>
--- a/weekly-tactics/01-market-research/NBC_Market_Research_Tactic.pptx
+++ b/weekly-tactics/01-market-research/NBC_Market_Research_Tactic.pptx
@@ -3071,7 +3071,7 @@
         </p:blipFill>
         <p:spPr>
           <a:xfrm>
-            <a:off x="5310187" y="3114973"/>
+            <a:off x="6724650" y="3120033"/>
             <a:ext cx="923925" cy="133350"/>
           </a:xfrm>
           <a:prstGeom prst="rect">
@@ -3876,7 +3876,7 @@
         </p:blipFill>
         <p:spPr>
           <a:xfrm>
-            <a:off x="4100513" y="3244900"/>
+            <a:off x="6062663" y="3244900"/>
             <a:ext cx="752475" cy="133350"/>
           </a:xfrm>
           <a:prstGeom prst="rect">
@@ -3902,7 +3902,7 @@
         </p:blipFill>
         <p:spPr>
           <a:xfrm>
-            <a:off x="4929188" y="3244900"/>
+            <a:off x="6891338" y="3244900"/>
             <a:ext cx="923925" cy="133350"/>
           </a:xfrm>
           <a:prstGeom prst="rect">

</xml_diff>